<commit_message>
Marketing materials: replace UQ monogram with SmartProps logo
Brochure (white header/footer) now uses the real SmartProps wordmark
(logo.svg, copied into marketing-materials for the file:// PDF render). The
one-pager band and the deck's drawn chip — both on colored backgrounds where a
full-color wordmark would clash — switch the "UQ" monogram to "SP". Regenerated
smartprops-brochure.pdf / smartprops-one-pager.pdf / smartprops-deck.pptx.

Co-Authored-By: Claude Opus 4.8 <noreply@anthropic.com>
</commit_message>
<xml_diff>
--- a/marketing-materials/smartprops-deck.pptx
+++ b/marketing-materials/smartprops-deck.pptx
@@ -1597,7 +1597,7 @@
                 <a:ea typeface="Georgia" pitchFamily="34" charset="-122"/>
                 <a:cs typeface="Georgia" pitchFamily="34" charset="-120"/>
               </a:rPr>
-              <a:t>UQ</a:t>
+              <a:t>SP</a:t>
             </a:r>
             <a:endParaRPr lang="en-US" sz="1600" dirty="0"/>
           </a:p>
@@ -7804,7 +7804,7 @@
                 <a:ea typeface="Georgia" pitchFamily="34" charset="-122"/>
                 <a:cs typeface="Georgia" pitchFamily="34" charset="-120"/>
               </a:rPr>
-              <a:t>UQ</a:t>
+              <a:t>SP</a:t>
             </a:r>
             <a:endParaRPr lang="en-US" sz="1600" dirty="0"/>
           </a:p>

</xml_diff>

<commit_message>
Marketing: remove all cost/plan pricing (site + brochure + one-pager + deck)
Pull pricing while it's being finalized. Remove the 5-tier pricing section/table
+ nav "Pricing" link from the marketing site and brochure (repoint the brochure's
#contact "Request access" CTAs to /beta since that anchor is gone), the deck's
pricing slide, and the founding-member-pricing bullet on the one-pager.
Regenerated brochure/one-pager PDFs + deck PPTX. Kept product-feature "pricing"
wording (build multi-option pricing, live pricing tables) — that's what the tool
does, not what it costs.

Co-Authored-By: Claude Opus 4.8 <noreply@anthropic.com>
</commit_message>
<xml_diff>
--- a/marketing-materials/smartprops-deck.pptx
+++ b/marketing-materials/smartprops-deck.pptx
@@ -12,10 +12,9 @@
     <p:sldId id="260" r:id="rId6"/>
     <p:sldId id="261" r:id="rId7"/>
     <p:sldId id="262" r:id="rId8"/>
-    <p:sldId id="263" r:id="rId9"/>
   </p:sldIdLst>
   <p:notesMasterIdLst>
-    <p:notesMasterId r:id="rId10"/>
+    <p:notesMasterId r:id="rId9"/>
   </p:notesMasterIdLst>
   <p:sldSz cx="12192000" cy="6858000"/>
   <p:notesSz cx="6858000" cy="12192000"/>
@@ -1079,94 +1078,6 @@
 </p:notes>
 </file>
 
-<file path=ppt/notesSlides/notesSlide8.xml><?xml version="1.0" encoding="utf-8"?>
-<p:notes xmlns:a="http://schemas.openxmlformats.org/drawingml/2006/main" xmlns:r="http://schemas.openxmlformats.org/officeDocument/2006/relationships" xmlns:p="http://schemas.openxmlformats.org/presentationml/2006/main">
-  <p:cSld>
-    <p:spTree>
-      <p:nvGrpSpPr>
-        <p:cNvPr id="1" name=""/>
-        <p:cNvGrpSpPr/>
-        <p:nvPr/>
-      </p:nvGrpSpPr>
-      <p:grpSpPr>
-        <a:xfrm>
-          <a:off x="0" y="0"/>
-          <a:ext cx="0" cy="0"/>
-          <a:chOff x="0" y="0"/>
-          <a:chExt cx="0" cy="0"/>
-        </a:xfrm>
-      </p:grpSpPr>
-      <p:sp>
-        <p:nvSpPr>
-          <p:cNvPr id="2" name="Slide Image Placeholder 1"/>
-          <p:cNvSpPr>
-            <a:spLocks noGrp="1" noRot="1" noChangeAspect="1"/>
-          </p:cNvSpPr>
-          <p:nvPr>
-            <p:ph type="sldImg"/>
-          </p:nvPr>
-        </p:nvSpPr>
-        <p:spPr/>
-      </p:sp>
-      <p:sp>
-        <p:nvSpPr>
-          <p:cNvPr id="3" name="Notes Placeholder 2"/>
-          <p:cNvSpPr>
-            <a:spLocks noGrp="1"/>
-          </p:cNvSpPr>
-          <p:nvPr>
-            <p:ph type="body" idx="1"/>
-          </p:nvPr>
-        </p:nvSpPr>
-        <p:spPr/>
-        <p:txBody>
-          <a:bodyPr/>
-          <a:lstStyle/>
-          <a:p>
-            <a:r>
-              <a:rPr lang="en-US" dirty="0"/>
-              <a:t/>
-            </a:r>
-            <a:endParaRPr lang="en-US" dirty="0"/>
-          </a:p>
-        </p:txBody>
-      </p:sp>
-      <p:sp>
-        <p:nvSpPr>
-          <p:cNvPr id="4" name="Slide Number Placeholder 3"/>
-          <p:cNvSpPr>
-            <a:spLocks noGrp="1"/>
-          </p:cNvSpPr>
-          <p:nvPr>
-            <p:ph type="sldNum" sz="quarter" idx="10"/>
-          </p:nvPr>
-        </p:nvSpPr>
-        <p:spPr/>
-        <p:txBody>
-          <a:bodyPr/>
-          <a:lstStyle/>
-          <a:p>
-            <a:fld id="{F7021451-1387-4CA6-816F-3879F97B5CBC}" type="slidenum">
-              <a:rPr lang="en-US"/>
-              <a:t>8</a:t>
-            </a:fld>
-            <a:endParaRPr lang="en-US"/>
-          </a:p>
-        </p:txBody>
-      </p:sp>
-    </p:spTree>
-    <p:extLst>
-      <p:ext uri="{BB962C8B-B14F-4D97-AF65-F5344CB8AC3E}">
-        <p14:creationId xmlns:p14="http://schemas.microsoft.com/office/powerpoint/2010/main" val="1024086991"/>
-      </p:ext>
-    </p:extLst>
-  </p:cSld>
-  <p:clrMapOvr>
-    <a:masterClrMapping/>
-  </p:clrMapOvr>
-</p:notes>
-</file>
-
 <file path=ppt/slideLayouts/slideLayout1.xml><?xml version="1.0" encoding="utf-8"?>
 <p:sldLayout xmlns:a="http://schemas.openxmlformats.org/drawingml/2006/main" xmlns:r="http://schemas.openxmlformats.org/officeDocument/2006/relationships" xmlns:p="http://schemas.openxmlformats.org/presentationml/2006/main" preserve="1">
   <p:cSld name="DEFAULT">
@@ -6074,1616 +5985,6 @@
 <file path=ppt/slides/slide7.xml><?xml version="1.0" encoding="utf-8"?>
 <p:sld xmlns:a="http://schemas.openxmlformats.org/drawingml/2006/main" xmlns:r="http://schemas.openxmlformats.org/officeDocument/2006/relationships" xmlns:p="http://schemas.openxmlformats.org/presentationml/2006/main">
   <p:cSld name="Slide 7">
-    <p:bg>
-      <p:bgPr>
-        <a:solidFill>
-          <a:srgbClr val="FFFFFF"/>
-        </a:solidFill>
-      </p:bgPr>
-    </p:bg>
-    <p:spTree>
-      <p:nvGrpSpPr>
-        <p:cNvPr id="1" name=""/>
-        <p:cNvGrpSpPr/>
-        <p:nvPr/>
-      </p:nvGrpSpPr>
-      <p:grpSpPr>
-        <a:xfrm>
-          <a:off x="0" y="0"/>
-          <a:ext cx="0" cy="0"/>
-          <a:chOff x="0" y="0"/>
-          <a:chExt cx="0" cy="0"/>
-        </a:xfrm>
-      </p:grpSpPr>
-      <p:sp>
-        <p:nvSpPr>
-          <p:cNvPr id="2" name="Text 0"/>
-          <p:cNvSpPr/>
-          <p:nvPr/>
-        </p:nvSpPr>
-        <p:spPr>
-          <a:xfrm>
-            <a:off x="822960" y="411480"/>
-            <a:ext cx="7315200" cy="274320"/>
-          </a:xfrm>
-          <a:prstGeom prst="rect">
-            <a:avLst/>
-          </a:prstGeom>
-          <a:noFill/>
-          <a:ln/>
-        </p:spPr>
-        <p:txBody>
-          <a:bodyPr wrap="square" lIns="0" tIns="0" rIns="0" bIns="0" rtlCol="0" anchor="ctr"/>
-          <a:lstStyle/>
-          <a:p>
-            <a:pPr indent="0" marL="0">
-              <a:buNone/>
-            </a:pPr>
-            <a:r>
-              <a:rPr lang="en-US" sz="1200" b="1" spc="200" kern="0" dirty="0">
-                <a:solidFill>
-                  <a:srgbClr val="3F6212"/>
-                </a:solidFill>
-                <a:latin typeface="Calibri" pitchFamily="34" charset="0"/>
-                <a:ea typeface="Calibri" pitchFamily="34" charset="-122"/>
-                <a:cs typeface="Calibri" pitchFamily="34" charset="-120"/>
-              </a:rPr>
-              <a:t>PRICING</a:t>
-            </a:r>
-            <a:endParaRPr lang="en-US" sz="1200" dirty="0"/>
-          </a:p>
-        </p:txBody>
-      </p:sp>
-      <p:sp>
-        <p:nvSpPr>
-          <p:cNvPr id="3" name="Text 1"/>
-          <p:cNvSpPr/>
-          <p:nvPr/>
-        </p:nvSpPr>
-        <p:spPr>
-          <a:xfrm>
-            <a:off x="822960" y="731520"/>
-            <a:ext cx="10515600" cy="640080"/>
-          </a:xfrm>
-          <a:prstGeom prst="rect">
-            <a:avLst/>
-          </a:prstGeom>
-          <a:noFill/>
-          <a:ln/>
-        </p:spPr>
-        <p:txBody>
-          <a:bodyPr wrap="square" lIns="0" tIns="0" rIns="0" bIns="0" rtlCol="0" anchor="ctr"/>
-          <a:lstStyle/>
-          <a:p>
-            <a:pPr indent="0" marL="0">
-              <a:buNone/>
-            </a:pPr>
-            <a:r>
-              <a:rPr lang="en-US" sz="2800" b="1" dirty="0">
-                <a:solidFill>
-                  <a:srgbClr val="0B1F3A"/>
-                </a:solidFill>
-                <a:latin typeface="Georgia" pitchFamily="34" charset="0"/>
-                <a:ea typeface="Georgia" pitchFamily="34" charset="-122"/>
-                <a:cs typeface="Georgia" pitchFamily="34" charset="-120"/>
-              </a:rPr>
-              <a:t>You only pay for documents that get signed.</a:t>
-            </a:r>
-            <a:endParaRPr lang="en-US" sz="2800" dirty="0"/>
-          </a:p>
-        </p:txBody>
-      </p:sp>
-      <p:sp>
-        <p:nvSpPr>
-          <p:cNvPr id="4" name="Text 2"/>
-          <p:cNvSpPr/>
-          <p:nvPr/>
-        </p:nvSpPr>
-        <p:spPr>
-          <a:xfrm>
-            <a:off x="822960" y="1371600"/>
-            <a:ext cx="10515600" cy="365760"/>
-          </a:xfrm>
-          <a:prstGeom prst="rect">
-            <a:avLst/>
-          </a:prstGeom>
-          <a:noFill/>
-          <a:ln/>
-        </p:spPr>
-        <p:txBody>
-          <a:bodyPr wrap="square" lIns="0" tIns="0" rIns="0" bIns="0" rtlCol="0" anchor="ctr"/>
-          <a:lstStyle/>
-          <a:p>
-            <a:pPr indent="0" marL="0">
-              <a:buNone/>
-            </a:pPr>
-            <a:r>
-              <a:rPr lang="en-US" sz="1400" dirty="0">
-                <a:solidFill>
-                  <a:srgbClr val="64748B"/>
-                </a:solidFill>
-                <a:latin typeface="Calibri" pitchFamily="34" charset="0"/>
-                <a:ea typeface="Calibri" pitchFamily="34" charset="-122"/>
-                <a:cs typeface="Calibri" pitchFamily="34" charset="-120"/>
-              </a:rPr>
-              <a:t>Proposals are always unlimited. We meter only completed (fully-signed) documents.</a:t>
-            </a:r>
-            <a:endParaRPr lang="en-US" sz="1400" dirty="0"/>
-          </a:p>
-        </p:txBody>
-      </p:sp>
-      <p:sp>
-        <p:nvSpPr>
-          <p:cNvPr id="5" name="Shape 3"/>
-          <p:cNvSpPr/>
-          <p:nvPr/>
-        </p:nvSpPr>
-        <p:spPr>
-          <a:xfrm>
-            <a:off x="484632" y="1965960"/>
-            <a:ext cx="2011680" cy="3657600"/>
-          </a:xfrm>
-          <a:prstGeom prst="rect">
-            <a:avLst/>
-          </a:prstGeom>
-          <a:solidFill>
-            <a:srgbClr val="FFFFFF"/>
-          </a:solidFill>
-          <a:ln w="12700">
-            <a:solidFill>
-              <a:srgbClr val="E2E8F0"/>
-            </a:solidFill>
-            <a:prstDash val="solid"/>
-          </a:ln>
-          <a:effectLst>
-            <a:outerShdw sx="100000" sy="100000" kx="0" ky="0" algn="bl" rotWithShape="0" blurRad="114300" dist="38100" dir="8100000">
-              <a:srgbClr val="0F172A">
-                <a:alpha val="12000"/>
-              </a:srgbClr>
-            </a:outerShdw>
-          </a:effectLst>
-        </p:spPr>
-      </p:sp>
-      <p:sp>
-        <p:nvSpPr>
-          <p:cNvPr id="6" name="Shape 4"/>
-          <p:cNvSpPr/>
-          <p:nvPr/>
-        </p:nvSpPr>
-        <p:spPr>
-          <a:xfrm>
-            <a:off x="484632" y="1965960"/>
-            <a:ext cx="2011680" cy="73152"/>
-          </a:xfrm>
-          <a:prstGeom prst="rect">
-            <a:avLst/>
-          </a:prstGeom>
-          <a:solidFill>
-            <a:srgbClr val="65A30D"/>
-          </a:solidFill>
-          <a:ln/>
-        </p:spPr>
-      </p:sp>
-      <p:sp>
-        <p:nvSpPr>
-          <p:cNvPr id="7" name="Text 5"/>
-          <p:cNvSpPr/>
-          <p:nvPr/>
-        </p:nvSpPr>
-        <p:spPr>
-          <a:xfrm>
-            <a:off x="667512" y="2240280"/>
-            <a:ext cx="1645920" cy="365760"/>
-          </a:xfrm>
-          <a:prstGeom prst="rect">
-            <a:avLst/>
-          </a:prstGeom>
-          <a:noFill/>
-          <a:ln/>
-        </p:spPr>
-        <p:txBody>
-          <a:bodyPr wrap="square" lIns="0" tIns="0" rIns="0" bIns="0" rtlCol="0" anchor="ctr"/>
-          <a:lstStyle/>
-          <a:p>
-            <a:pPr indent="0" marL="0">
-              <a:buNone/>
-            </a:pPr>
-            <a:r>
-              <a:rPr lang="en-US" sz="1600" b="1" dirty="0">
-                <a:solidFill>
-                  <a:srgbClr val="0B1F3A"/>
-                </a:solidFill>
-                <a:latin typeface="Georgia" pitchFamily="34" charset="0"/>
-                <a:ea typeface="Georgia" pitchFamily="34" charset="-122"/>
-                <a:cs typeface="Georgia" pitchFamily="34" charset="-120"/>
-              </a:rPr>
-              <a:t>Pay-per-use</a:t>
-            </a:r>
-            <a:endParaRPr lang="en-US" sz="1600" dirty="0"/>
-          </a:p>
-        </p:txBody>
-      </p:sp>
-      <p:sp>
-        <p:nvSpPr>
-          <p:cNvPr id="8" name="Text 6"/>
-          <p:cNvSpPr/>
-          <p:nvPr/>
-        </p:nvSpPr>
-        <p:spPr>
-          <a:xfrm>
-            <a:off x="667512" y="2624328"/>
-            <a:ext cx="1645920" cy="502920"/>
-          </a:xfrm>
-          <a:prstGeom prst="rect">
-            <a:avLst/>
-          </a:prstGeom>
-          <a:noFill/>
-          <a:ln/>
-        </p:spPr>
-        <p:txBody>
-          <a:bodyPr wrap="square" lIns="0" tIns="0" rIns="0" bIns="0" rtlCol="0" anchor="ctr"/>
-          <a:lstStyle/>
-          <a:p>
-            <a:pPr indent="0" marL="0">
-              <a:buNone/>
-            </a:pPr>
-            <a:r>
-              <a:rPr lang="en-US" sz="2800" b="1" dirty="0">
-                <a:solidFill>
-                  <a:srgbClr val="0B1F3A"/>
-                </a:solidFill>
-                <a:latin typeface="Georgia" pitchFamily="34" charset="0"/>
-                <a:ea typeface="Georgia" pitchFamily="34" charset="-122"/>
-                <a:cs typeface="Georgia" pitchFamily="34" charset="-120"/>
-              </a:rPr>
-              <a:t>$9</a:t>
-            </a:r>
-            <a:pPr indent="0" marL="0">
-              <a:buNone/>
-            </a:pPr>
-            <a:r>
-              <a:rPr lang="en-US" sz="1050" dirty="0">
-                <a:solidFill>
-                  <a:srgbClr val="64748B"/>
-                </a:solidFill>
-                <a:latin typeface="Georgia" pitchFamily="34" charset="0"/>
-                <a:ea typeface="Georgia" pitchFamily="34" charset="-122"/>
-                <a:cs typeface="Georgia" pitchFamily="34" charset="-120"/>
-              </a:rPr>
-              <a:t> / signed doc</a:t>
-            </a:r>
-            <a:endParaRPr lang="en-US" sz="2800" dirty="0"/>
-          </a:p>
-        </p:txBody>
-      </p:sp>
-      <p:sp>
-        <p:nvSpPr>
-          <p:cNvPr id="9" name="Text 7"/>
-          <p:cNvSpPr/>
-          <p:nvPr/>
-        </p:nvSpPr>
-        <p:spPr>
-          <a:xfrm>
-            <a:off x="667512" y="3227832"/>
-            <a:ext cx="1645920" cy="320040"/>
-          </a:xfrm>
-          <a:prstGeom prst="rect">
-            <a:avLst/>
-          </a:prstGeom>
-          <a:noFill/>
-          <a:ln/>
-        </p:spPr>
-        <p:txBody>
-          <a:bodyPr wrap="square" lIns="0" tIns="0" rIns="0" bIns="0" rtlCol="0" anchor="ctr"/>
-          <a:lstStyle/>
-          <a:p>
-            <a:pPr indent="0" marL="0">
-              <a:buNone/>
-            </a:pPr>
-            <a:r>
-              <a:rPr lang="en-US" sz="1050" b="1" dirty="0">
-                <a:solidFill>
-                  <a:srgbClr val="3F6212"/>
-                </a:solidFill>
-                <a:latin typeface="Calibri" pitchFamily="34" charset="0"/>
-                <a:ea typeface="Calibri" pitchFamily="34" charset="-122"/>
-                <a:cs typeface="Calibri" pitchFamily="34" charset="-120"/>
-              </a:rPr>
-              <a:t>$0 base · pay as you go</a:t>
-            </a:r>
-            <a:endParaRPr lang="en-US" sz="1050" dirty="0"/>
-          </a:p>
-        </p:txBody>
-      </p:sp>
-      <p:sp>
-        <p:nvSpPr>
-          <p:cNvPr id="10" name="Text 8"/>
-          <p:cNvSpPr/>
-          <p:nvPr/>
-        </p:nvSpPr>
-        <p:spPr>
-          <a:xfrm>
-            <a:off x="667512" y="3611880"/>
-            <a:ext cx="1645920" cy="1737360"/>
-          </a:xfrm>
-          <a:prstGeom prst="rect">
-            <a:avLst/>
-          </a:prstGeom>
-          <a:noFill/>
-          <a:ln/>
-        </p:spPr>
-        <p:txBody>
-          <a:bodyPr wrap="square" lIns="0" tIns="0" rIns="0" bIns="0" rtlCol="0" anchor="ctr"/>
-          <a:lstStyle/>
-          <a:p>
-            <a:pPr marL="152400" indent="-152400">
-              <a:spcAft>
-                <a:spcPts val="400"/>
-              </a:spcAft>
-              <a:buSzPct val="100000"/>
-              <a:buChar char="✓"/>
-            </a:pPr>
-            <a:r>
-              <a:rPr lang="en-US" sz="1050" dirty="0">
-                <a:solidFill>
-                  <a:srgbClr val="1E293B"/>
-                </a:solidFill>
-                <a:latin typeface="Calibri" pitchFamily="34" charset="0"/>
-                <a:ea typeface="Calibri" pitchFamily="34" charset="-122"/>
-                <a:cs typeface="Calibri" pitchFamily="34" charset="-120"/>
-              </a:rPr>
-              <a:t>1 user</a:t>
-            </a:r>
-            <a:endParaRPr lang="en-US" sz="1050" dirty="0"/>
-          </a:p>
-          <a:p>
-            <a:pPr marL="152400" indent="-152400">
-              <a:spcAft>
-                <a:spcPts val="400"/>
-              </a:spcAft>
-              <a:buSzPct val="100000"/>
-              <a:buChar char="✓"/>
-            </a:pPr>
-            <a:r>
-              <a:rPr lang="en-US" sz="1050" dirty="0">
-                <a:solidFill>
-                  <a:srgbClr val="1E293B"/>
-                </a:solidFill>
-                <a:latin typeface="Calibri" pitchFamily="34" charset="0"/>
-                <a:ea typeface="Calibri" pitchFamily="34" charset="-122"/>
-                <a:cs typeface="Calibri" pitchFamily="34" charset="-120"/>
-              </a:rPr>
-              <a:t>Unlimited proposals</a:t>
-            </a:r>
-            <a:endParaRPr lang="en-US" sz="1050" dirty="0"/>
-          </a:p>
-          <a:p>
-            <a:pPr marL="152400" indent="-152400">
-              <a:spcAft>
-                <a:spcPts val="400"/>
-              </a:spcAft>
-              <a:buSzPct val="100000"/>
-              <a:buChar char="✓"/>
-            </a:pPr>
-            <a:r>
-              <a:rPr lang="en-US" sz="1050" dirty="0">
-                <a:solidFill>
-                  <a:srgbClr val="1E293B"/>
-                </a:solidFill>
-                <a:latin typeface="Calibri" pitchFamily="34" charset="0"/>
-                <a:ea typeface="Calibri" pitchFamily="34" charset="-122"/>
-                <a:cs typeface="Calibri" pitchFamily="34" charset="-120"/>
-              </a:rPr>
-              <a:t>All features</a:t>
-            </a:r>
-            <a:endParaRPr lang="en-US" sz="1050" dirty="0"/>
-          </a:p>
-          <a:p>
-            <a:pPr marL="152400" indent="-152400">
-              <a:spcAft>
-                <a:spcPts val="400"/>
-              </a:spcAft>
-              <a:buSzPct val="100000"/>
-              <a:buChar char="✓"/>
-            </a:pPr>
-            <a:r>
-              <a:rPr lang="en-US" sz="1050" dirty="0">
-                <a:solidFill>
-                  <a:srgbClr val="1E293B"/>
-                </a:solidFill>
-                <a:latin typeface="Calibri" pitchFamily="34" charset="0"/>
-                <a:ea typeface="Calibri" pitchFamily="34" charset="-122"/>
-                <a:cs typeface="Calibri" pitchFamily="34" charset="-120"/>
-              </a:rPr>
-              <a:t>No commitment</a:t>
-            </a:r>
-            <a:endParaRPr lang="en-US" sz="1050" dirty="0"/>
-          </a:p>
-        </p:txBody>
-      </p:sp>
-      <p:sp>
-        <p:nvSpPr>
-          <p:cNvPr id="11" name="Shape 9"/>
-          <p:cNvSpPr/>
-          <p:nvPr/>
-        </p:nvSpPr>
-        <p:spPr>
-          <a:xfrm>
-            <a:off x="2779776" y="1965960"/>
-            <a:ext cx="2011680" cy="3657600"/>
-          </a:xfrm>
-          <a:prstGeom prst="rect">
-            <a:avLst/>
-          </a:prstGeom>
-          <a:solidFill>
-            <a:srgbClr val="FFFFFF"/>
-          </a:solidFill>
-          <a:ln w="12700">
-            <a:solidFill>
-              <a:srgbClr val="E2E8F0"/>
-            </a:solidFill>
-            <a:prstDash val="solid"/>
-          </a:ln>
-          <a:effectLst>
-            <a:outerShdw sx="100000" sy="100000" kx="0" ky="0" algn="bl" rotWithShape="0" blurRad="114300" dist="38100" dir="8100000">
-              <a:srgbClr val="0F172A">
-                <a:alpha val="12000"/>
-              </a:srgbClr>
-            </a:outerShdw>
-          </a:effectLst>
-        </p:spPr>
-      </p:sp>
-      <p:sp>
-        <p:nvSpPr>
-          <p:cNvPr id="12" name="Shape 10"/>
-          <p:cNvSpPr/>
-          <p:nvPr/>
-        </p:nvSpPr>
-        <p:spPr>
-          <a:xfrm>
-            <a:off x="2779776" y="1965960"/>
-            <a:ext cx="2011680" cy="73152"/>
-          </a:xfrm>
-          <a:prstGeom prst="rect">
-            <a:avLst/>
-          </a:prstGeom>
-          <a:solidFill>
-            <a:srgbClr val="65A30D"/>
-          </a:solidFill>
-          <a:ln/>
-        </p:spPr>
-      </p:sp>
-      <p:sp>
-        <p:nvSpPr>
-          <p:cNvPr id="13" name="Text 11"/>
-          <p:cNvSpPr/>
-          <p:nvPr/>
-        </p:nvSpPr>
-        <p:spPr>
-          <a:xfrm>
-            <a:off x="2962656" y="2240280"/>
-            <a:ext cx="1645920" cy="365760"/>
-          </a:xfrm>
-          <a:prstGeom prst="rect">
-            <a:avLst/>
-          </a:prstGeom>
-          <a:noFill/>
-          <a:ln/>
-        </p:spPr>
-        <p:txBody>
-          <a:bodyPr wrap="square" lIns="0" tIns="0" rIns="0" bIns="0" rtlCol="0" anchor="ctr"/>
-          <a:lstStyle/>
-          <a:p>
-            <a:pPr indent="0" marL="0">
-              <a:buNone/>
-            </a:pPr>
-            <a:r>
-              <a:rPr lang="en-US" sz="1600" b="1" dirty="0">
-                <a:solidFill>
-                  <a:srgbClr val="0B1F3A"/>
-                </a:solidFill>
-                <a:latin typeface="Georgia" pitchFamily="34" charset="0"/>
-                <a:ea typeface="Georgia" pitchFamily="34" charset="-122"/>
-                <a:cs typeface="Georgia" pitchFamily="34" charset="-120"/>
-              </a:rPr>
-              <a:t>Starter</a:t>
-            </a:r>
-            <a:endParaRPr lang="en-US" sz="1600" dirty="0"/>
-          </a:p>
-        </p:txBody>
-      </p:sp>
-      <p:sp>
-        <p:nvSpPr>
-          <p:cNvPr id="14" name="Text 12"/>
-          <p:cNvSpPr/>
-          <p:nvPr/>
-        </p:nvSpPr>
-        <p:spPr>
-          <a:xfrm>
-            <a:off x="2962656" y="2624328"/>
-            <a:ext cx="1645920" cy="502920"/>
-          </a:xfrm>
-          <a:prstGeom prst="rect">
-            <a:avLst/>
-          </a:prstGeom>
-          <a:noFill/>
-          <a:ln/>
-        </p:spPr>
-        <p:txBody>
-          <a:bodyPr wrap="square" lIns="0" tIns="0" rIns="0" bIns="0" rtlCol="0" anchor="ctr"/>
-          <a:lstStyle/>
-          <a:p>
-            <a:pPr indent="0" marL="0">
-              <a:buNone/>
-            </a:pPr>
-            <a:r>
-              <a:rPr lang="en-US" sz="2800" b="1" dirty="0">
-                <a:solidFill>
-                  <a:srgbClr val="0B1F3A"/>
-                </a:solidFill>
-                <a:latin typeface="Georgia" pitchFamily="34" charset="0"/>
-                <a:ea typeface="Georgia" pitchFamily="34" charset="-122"/>
-                <a:cs typeface="Georgia" pitchFamily="34" charset="-120"/>
-              </a:rPr>
-              <a:t>$30</a:t>
-            </a:r>
-            <a:pPr indent="0" marL="0">
-              <a:buNone/>
-            </a:pPr>
-            <a:r>
-              <a:rPr lang="en-US" sz="1050" dirty="0">
-                <a:solidFill>
-                  <a:srgbClr val="64748B"/>
-                </a:solidFill>
-                <a:latin typeface="Georgia" pitchFamily="34" charset="0"/>
-                <a:ea typeface="Georgia" pitchFamily="34" charset="-122"/>
-                <a:cs typeface="Georgia" pitchFamily="34" charset="-120"/>
-              </a:rPr>
-              <a:t> / mo</a:t>
-            </a:r>
-            <a:endParaRPr lang="en-US" sz="2800" dirty="0"/>
-          </a:p>
-        </p:txBody>
-      </p:sp>
-      <p:sp>
-        <p:nvSpPr>
-          <p:cNvPr id="15" name="Text 13"/>
-          <p:cNvSpPr/>
-          <p:nvPr/>
-        </p:nvSpPr>
-        <p:spPr>
-          <a:xfrm>
-            <a:off x="2962656" y="3227832"/>
-            <a:ext cx="1645920" cy="320040"/>
-          </a:xfrm>
-          <a:prstGeom prst="rect">
-            <a:avLst/>
-          </a:prstGeom>
-          <a:noFill/>
-          <a:ln/>
-        </p:spPr>
-        <p:txBody>
-          <a:bodyPr wrap="square" lIns="0" tIns="0" rIns="0" bIns="0" rtlCol="0" anchor="ctr"/>
-          <a:lstStyle/>
-          <a:p>
-            <a:pPr indent="0" marL="0">
-              <a:buNone/>
-            </a:pPr>
-            <a:r>
-              <a:rPr lang="en-US" sz="1050" b="1" dirty="0">
-                <a:solidFill>
-                  <a:srgbClr val="3F6212"/>
-                </a:solidFill>
-                <a:latin typeface="Calibri" pitchFamily="34" charset="0"/>
-                <a:ea typeface="Calibri" pitchFamily="34" charset="-122"/>
-                <a:cs typeface="Calibri" pitchFamily="34" charset="-120"/>
-              </a:rPr>
-              <a:t>5 signed docs / mo</a:t>
-            </a:r>
-            <a:endParaRPr lang="en-US" sz="1050" dirty="0"/>
-          </a:p>
-        </p:txBody>
-      </p:sp>
-      <p:sp>
-        <p:nvSpPr>
-          <p:cNvPr id="16" name="Text 14"/>
-          <p:cNvSpPr/>
-          <p:nvPr/>
-        </p:nvSpPr>
-        <p:spPr>
-          <a:xfrm>
-            <a:off x="2962656" y="3611880"/>
-            <a:ext cx="1645920" cy="1737360"/>
-          </a:xfrm>
-          <a:prstGeom prst="rect">
-            <a:avLst/>
-          </a:prstGeom>
-          <a:noFill/>
-          <a:ln/>
-        </p:spPr>
-        <p:txBody>
-          <a:bodyPr wrap="square" lIns="0" tIns="0" rIns="0" bIns="0" rtlCol="0" anchor="ctr"/>
-          <a:lstStyle/>
-          <a:p>
-            <a:pPr marL="152400" indent="-152400">
-              <a:spcAft>
-                <a:spcPts val="400"/>
-              </a:spcAft>
-              <a:buSzPct val="100000"/>
-              <a:buChar char="✓"/>
-            </a:pPr>
-            <a:r>
-              <a:rPr lang="en-US" sz="1050" dirty="0">
-                <a:solidFill>
-                  <a:srgbClr val="1E293B"/>
-                </a:solidFill>
-                <a:latin typeface="Calibri" pitchFamily="34" charset="0"/>
-                <a:ea typeface="Calibri" pitchFamily="34" charset="-122"/>
-                <a:cs typeface="Calibri" pitchFamily="34" charset="-120"/>
-              </a:rPr>
-              <a:t>1 user</a:t>
-            </a:r>
-            <a:endParaRPr lang="en-US" sz="1050" dirty="0"/>
-          </a:p>
-          <a:p>
-            <a:pPr marL="152400" indent="-152400">
-              <a:spcAft>
-                <a:spcPts val="400"/>
-              </a:spcAft>
-              <a:buSzPct val="100000"/>
-              <a:buChar char="✓"/>
-            </a:pPr>
-            <a:r>
-              <a:rPr lang="en-US" sz="1050" dirty="0">
-                <a:solidFill>
-                  <a:srgbClr val="1E293B"/>
-                </a:solidFill>
-                <a:latin typeface="Calibri" pitchFamily="34" charset="0"/>
-                <a:ea typeface="Calibri" pitchFamily="34" charset="-122"/>
-                <a:cs typeface="Calibri" pitchFamily="34" charset="-120"/>
-              </a:rPr>
-              <a:t>$3 / extra doc</a:t>
-            </a:r>
-            <a:endParaRPr lang="en-US" sz="1050" dirty="0"/>
-          </a:p>
-          <a:p>
-            <a:pPr marL="152400" indent="-152400">
-              <a:spcAft>
-                <a:spcPts val="400"/>
-              </a:spcAft>
-              <a:buSzPct val="100000"/>
-              <a:buChar char="✓"/>
-            </a:pPr>
-            <a:r>
-              <a:rPr lang="en-US" sz="1050" dirty="0">
-                <a:solidFill>
-                  <a:srgbClr val="1E293B"/>
-                </a:solidFill>
-                <a:latin typeface="Calibri" pitchFamily="34" charset="0"/>
-                <a:ea typeface="Calibri" pitchFamily="34" charset="-122"/>
-                <a:cs typeface="Calibri" pitchFamily="34" charset="-120"/>
-              </a:rPr>
-              <a:t>Unlimited proposals</a:t>
-            </a:r>
-            <a:endParaRPr lang="en-US" sz="1050" dirty="0"/>
-          </a:p>
-          <a:p>
-            <a:pPr marL="152400" indent="-152400">
-              <a:spcAft>
-                <a:spcPts val="400"/>
-              </a:spcAft>
-              <a:buSzPct val="100000"/>
-              <a:buChar char="✓"/>
-            </a:pPr>
-            <a:r>
-              <a:rPr lang="en-US" sz="1050" dirty="0">
-                <a:solidFill>
-                  <a:srgbClr val="1E293B"/>
-                </a:solidFill>
-                <a:latin typeface="Calibri" pitchFamily="34" charset="0"/>
-                <a:ea typeface="Calibri" pitchFamily="34" charset="-122"/>
-                <a:cs typeface="Calibri" pitchFamily="34" charset="-120"/>
-              </a:rPr>
-              <a:t>All features</a:t>
-            </a:r>
-            <a:endParaRPr lang="en-US" sz="1050" dirty="0"/>
-          </a:p>
-        </p:txBody>
-      </p:sp>
-      <p:sp>
-        <p:nvSpPr>
-          <p:cNvPr id="17" name="Shape 15"/>
-          <p:cNvSpPr/>
-          <p:nvPr/>
-        </p:nvSpPr>
-        <p:spPr>
-          <a:xfrm>
-            <a:off x="5074920" y="1965960"/>
-            <a:ext cx="2011680" cy="3657600"/>
-          </a:xfrm>
-          <a:prstGeom prst="rect">
-            <a:avLst/>
-          </a:prstGeom>
-          <a:solidFill>
-            <a:srgbClr val="FFFFFF"/>
-          </a:solidFill>
-          <a:ln w="12700">
-            <a:solidFill>
-              <a:srgbClr val="E2E8F0"/>
-            </a:solidFill>
-            <a:prstDash val="solid"/>
-          </a:ln>
-          <a:effectLst>
-            <a:outerShdw sx="100000" sy="100000" kx="0" ky="0" algn="bl" rotWithShape="0" blurRad="114300" dist="38100" dir="8100000">
-              <a:srgbClr val="0F172A">
-                <a:alpha val="12000"/>
-              </a:srgbClr>
-            </a:outerShdw>
-          </a:effectLst>
-        </p:spPr>
-      </p:sp>
-      <p:sp>
-        <p:nvSpPr>
-          <p:cNvPr id="18" name="Shape 16"/>
-          <p:cNvSpPr/>
-          <p:nvPr/>
-        </p:nvSpPr>
-        <p:spPr>
-          <a:xfrm>
-            <a:off x="5074920" y="1965960"/>
-            <a:ext cx="2011680" cy="73152"/>
-          </a:xfrm>
-          <a:prstGeom prst="rect">
-            <a:avLst/>
-          </a:prstGeom>
-          <a:solidFill>
-            <a:srgbClr val="65A30D"/>
-          </a:solidFill>
-          <a:ln/>
-        </p:spPr>
-      </p:sp>
-      <p:sp>
-        <p:nvSpPr>
-          <p:cNvPr id="19" name="Text 17"/>
-          <p:cNvSpPr/>
-          <p:nvPr/>
-        </p:nvSpPr>
-        <p:spPr>
-          <a:xfrm>
-            <a:off x="5257800" y="2240280"/>
-            <a:ext cx="1645920" cy="365760"/>
-          </a:xfrm>
-          <a:prstGeom prst="rect">
-            <a:avLst/>
-          </a:prstGeom>
-          <a:noFill/>
-          <a:ln/>
-        </p:spPr>
-        <p:txBody>
-          <a:bodyPr wrap="square" lIns="0" tIns="0" rIns="0" bIns="0" rtlCol="0" anchor="ctr"/>
-          <a:lstStyle/>
-          <a:p>
-            <a:pPr indent="0" marL="0">
-              <a:buNone/>
-            </a:pPr>
-            <a:r>
-              <a:rPr lang="en-US" sz="1600" b="1" dirty="0">
-                <a:solidFill>
-                  <a:srgbClr val="0B1F3A"/>
-                </a:solidFill>
-                <a:latin typeface="Georgia" pitchFamily="34" charset="0"/>
-                <a:ea typeface="Georgia" pitchFamily="34" charset="-122"/>
-                <a:cs typeface="Georgia" pitchFamily="34" charset="-120"/>
-              </a:rPr>
-              <a:t>Standard</a:t>
-            </a:r>
-            <a:endParaRPr lang="en-US" sz="1600" dirty="0"/>
-          </a:p>
-        </p:txBody>
-      </p:sp>
-      <p:sp>
-        <p:nvSpPr>
-          <p:cNvPr id="20" name="Text 18"/>
-          <p:cNvSpPr/>
-          <p:nvPr/>
-        </p:nvSpPr>
-        <p:spPr>
-          <a:xfrm>
-            <a:off x="5257800" y="2624328"/>
-            <a:ext cx="1645920" cy="502920"/>
-          </a:xfrm>
-          <a:prstGeom prst="rect">
-            <a:avLst/>
-          </a:prstGeom>
-          <a:noFill/>
-          <a:ln/>
-        </p:spPr>
-        <p:txBody>
-          <a:bodyPr wrap="square" lIns="0" tIns="0" rIns="0" bIns="0" rtlCol="0" anchor="ctr"/>
-          <a:lstStyle/>
-          <a:p>
-            <a:pPr indent="0" marL="0">
-              <a:buNone/>
-            </a:pPr>
-            <a:r>
-              <a:rPr lang="en-US" sz="2800" b="1" dirty="0">
-                <a:solidFill>
-                  <a:srgbClr val="0B1F3A"/>
-                </a:solidFill>
-                <a:latin typeface="Georgia" pitchFamily="34" charset="0"/>
-                <a:ea typeface="Georgia" pitchFamily="34" charset="-122"/>
-                <a:cs typeface="Georgia" pitchFamily="34" charset="-120"/>
-              </a:rPr>
-              <a:t>$50</a:t>
-            </a:r>
-            <a:pPr indent="0" marL="0">
-              <a:buNone/>
-            </a:pPr>
-            <a:r>
-              <a:rPr lang="en-US" sz="1050" dirty="0">
-                <a:solidFill>
-                  <a:srgbClr val="64748B"/>
-                </a:solidFill>
-                <a:latin typeface="Georgia" pitchFamily="34" charset="0"/>
-                <a:ea typeface="Georgia" pitchFamily="34" charset="-122"/>
-                <a:cs typeface="Georgia" pitchFamily="34" charset="-120"/>
-              </a:rPr>
-              <a:t> / mo</a:t>
-            </a:r>
-            <a:endParaRPr lang="en-US" sz="2800" dirty="0"/>
-          </a:p>
-        </p:txBody>
-      </p:sp>
-      <p:sp>
-        <p:nvSpPr>
-          <p:cNvPr id="21" name="Text 19"/>
-          <p:cNvSpPr/>
-          <p:nvPr/>
-        </p:nvSpPr>
-        <p:spPr>
-          <a:xfrm>
-            <a:off x="5257800" y="3227832"/>
-            <a:ext cx="1645920" cy="320040"/>
-          </a:xfrm>
-          <a:prstGeom prst="rect">
-            <a:avLst/>
-          </a:prstGeom>
-          <a:noFill/>
-          <a:ln/>
-        </p:spPr>
-        <p:txBody>
-          <a:bodyPr wrap="square" lIns="0" tIns="0" rIns="0" bIns="0" rtlCol="0" anchor="ctr"/>
-          <a:lstStyle/>
-          <a:p>
-            <a:pPr indent="0" marL="0">
-              <a:buNone/>
-            </a:pPr>
-            <a:r>
-              <a:rPr lang="en-US" sz="1050" b="1" dirty="0">
-                <a:solidFill>
-                  <a:srgbClr val="3F6212"/>
-                </a:solidFill>
-                <a:latin typeface="Calibri" pitchFamily="34" charset="0"/>
-                <a:ea typeface="Calibri" pitchFamily="34" charset="-122"/>
-                <a:cs typeface="Calibri" pitchFamily="34" charset="-120"/>
-              </a:rPr>
-              <a:t>10 signed docs / mo</a:t>
-            </a:r>
-            <a:endParaRPr lang="en-US" sz="1050" dirty="0"/>
-          </a:p>
-        </p:txBody>
-      </p:sp>
-      <p:sp>
-        <p:nvSpPr>
-          <p:cNvPr id="22" name="Text 20"/>
-          <p:cNvSpPr/>
-          <p:nvPr/>
-        </p:nvSpPr>
-        <p:spPr>
-          <a:xfrm>
-            <a:off x="5257800" y="3611880"/>
-            <a:ext cx="1645920" cy="1737360"/>
-          </a:xfrm>
-          <a:prstGeom prst="rect">
-            <a:avLst/>
-          </a:prstGeom>
-          <a:noFill/>
-          <a:ln/>
-        </p:spPr>
-        <p:txBody>
-          <a:bodyPr wrap="square" lIns="0" tIns="0" rIns="0" bIns="0" rtlCol="0" anchor="ctr"/>
-          <a:lstStyle/>
-          <a:p>
-            <a:pPr marL="152400" indent="-152400">
-              <a:spcAft>
-                <a:spcPts val="400"/>
-              </a:spcAft>
-              <a:buSzPct val="100000"/>
-              <a:buChar char="✓"/>
-            </a:pPr>
-            <a:r>
-              <a:rPr lang="en-US" sz="1050" dirty="0">
-                <a:solidFill>
-                  <a:srgbClr val="1E293B"/>
-                </a:solidFill>
-                <a:latin typeface="Calibri" pitchFamily="34" charset="0"/>
-                <a:ea typeface="Calibri" pitchFamily="34" charset="-122"/>
-                <a:cs typeface="Calibri" pitchFamily="34" charset="-120"/>
-              </a:rPr>
-              <a:t>2 users</a:t>
-            </a:r>
-            <a:endParaRPr lang="en-US" sz="1050" dirty="0"/>
-          </a:p>
-          <a:p>
-            <a:pPr marL="152400" indent="-152400">
-              <a:spcAft>
-                <a:spcPts val="400"/>
-              </a:spcAft>
-              <a:buSzPct val="100000"/>
-              <a:buChar char="✓"/>
-            </a:pPr>
-            <a:r>
-              <a:rPr lang="en-US" sz="1050" dirty="0">
-                <a:solidFill>
-                  <a:srgbClr val="1E293B"/>
-                </a:solidFill>
-                <a:latin typeface="Calibri" pitchFamily="34" charset="0"/>
-                <a:ea typeface="Calibri" pitchFamily="34" charset="-122"/>
-                <a:cs typeface="Calibri" pitchFamily="34" charset="-120"/>
-              </a:rPr>
-              <a:t>$3 / extra doc</a:t>
-            </a:r>
-            <a:endParaRPr lang="en-US" sz="1050" dirty="0"/>
-          </a:p>
-          <a:p>
-            <a:pPr marL="152400" indent="-152400">
-              <a:spcAft>
-                <a:spcPts val="400"/>
-              </a:spcAft>
-              <a:buSzPct val="100000"/>
-              <a:buChar char="✓"/>
-            </a:pPr>
-            <a:r>
-              <a:rPr lang="en-US" sz="1050" dirty="0">
-                <a:solidFill>
-                  <a:srgbClr val="1E293B"/>
-                </a:solidFill>
-                <a:latin typeface="Calibri" pitchFamily="34" charset="0"/>
-                <a:ea typeface="Calibri" pitchFamily="34" charset="-122"/>
-                <a:cs typeface="Calibri" pitchFamily="34" charset="-120"/>
-              </a:rPr>
-              <a:t>Everything in Starter</a:t>
-            </a:r>
-            <a:endParaRPr lang="en-US" sz="1050" dirty="0"/>
-          </a:p>
-        </p:txBody>
-      </p:sp>
-      <p:sp>
-        <p:nvSpPr>
-          <p:cNvPr id="23" name="Shape 21"/>
-          <p:cNvSpPr/>
-          <p:nvPr/>
-        </p:nvSpPr>
-        <p:spPr>
-          <a:xfrm>
-            <a:off x="7370064" y="1783080"/>
-            <a:ext cx="2011680" cy="3977640"/>
-          </a:xfrm>
-          <a:prstGeom prst="rect">
-            <a:avLst/>
-          </a:prstGeom>
-          <a:solidFill>
-            <a:srgbClr val="0B1F3A"/>
-          </a:solidFill>
-          <a:ln w="12700">
-            <a:solidFill>
-              <a:srgbClr val="0B1F3A"/>
-            </a:solidFill>
-            <a:prstDash val="solid"/>
-          </a:ln>
-          <a:effectLst>
-            <a:outerShdw sx="100000" sy="100000" kx="0" ky="0" algn="bl" rotWithShape="0" blurRad="114300" dist="38100" dir="8100000">
-              <a:srgbClr val="0F172A">
-                <a:alpha val="12000"/>
-              </a:srgbClr>
-            </a:outerShdw>
-          </a:effectLst>
-        </p:spPr>
-      </p:sp>
-      <p:sp>
-        <p:nvSpPr>
-          <p:cNvPr id="24" name="Text 22"/>
-          <p:cNvSpPr/>
-          <p:nvPr/>
-        </p:nvSpPr>
-        <p:spPr>
-          <a:xfrm>
-            <a:off x="7370064" y="1947672"/>
-            <a:ext cx="2011680" cy="274320"/>
-          </a:xfrm>
-          <a:prstGeom prst="rect">
-            <a:avLst/>
-          </a:prstGeom>
-          <a:noFill/>
-          <a:ln/>
-        </p:spPr>
-        <p:txBody>
-          <a:bodyPr wrap="square" lIns="0" tIns="0" rIns="0" bIns="0" rtlCol="0" anchor="ctr"/>
-          <a:lstStyle/>
-          <a:p>
-            <a:pPr algn="ctr" indent="0" marL="0">
-              <a:buNone/>
-            </a:pPr>
-            <a:r>
-              <a:rPr lang="en-US" sz="900" b="1" spc="150" kern="0" dirty="0">
-                <a:solidFill>
-                  <a:srgbClr val="5EEAD4"/>
-                </a:solidFill>
-                <a:latin typeface="Calibri" pitchFamily="34" charset="0"/>
-                <a:ea typeface="Calibri" pitchFamily="34" charset="-122"/>
-                <a:cs typeface="Calibri" pitchFamily="34" charset="-120"/>
-              </a:rPr>
-              <a:t>MOST POPULAR</a:t>
-            </a:r>
-            <a:endParaRPr lang="en-US" sz="900" dirty="0"/>
-          </a:p>
-        </p:txBody>
-      </p:sp>
-      <p:sp>
-        <p:nvSpPr>
-          <p:cNvPr id="25" name="Text 23"/>
-          <p:cNvSpPr/>
-          <p:nvPr/>
-        </p:nvSpPr>
-        <p:spPr>
-          <a:xfrm>
-            <a:off x="7552944" y="2286000"/>
-            <a:ext cx="1645920" cy="365760"/>
-          </a:xfrm>
-          <a:prstGeom prst="rect">
-            <a:avLst/>
-          </a:prstGeom>
-          <a:noFill/>
-          <a:ln/>
-        </p:spPr>
-        <p:txBody>
-          <a:bodyPr wrap="square" lIns="0" tIns="0" rIns="0" bIns="0" rtlCol="0" anchor="ctr"/>
-          <a:lstStyle/>
-          <a:p>
-            <a:pPr indent="0" marL="0">
-              <a:buNone/>
-            </a:pPr>
-            <a:r>
-              <a:rPr lang="en-US" sz="1600" b="1" dirty="0">
-                <a:solidFill>
-                  <a:srgbClr val="FFFFFF"/>
-                </a:solidFill>
-                <a:latin typeface="Georgia" pitchFamily="34" charset="0"/>
-                <a:ea typeface="Georgia" pitchFamily="34" charset="-122"/>
-                <a:cs typeface="Georgia" pitchFamily="34" charset="-120"/>
-              </a:rPr>
-              <a:t>Pro</a:t>
-            </a:r>
-            <a:endParaRPr lang="en-US" sz="1600" dirty="0"/>
-          </a:p>
-        </p:txBody>
-      </p:sp>
-      <p:sp>
-        <p:nvSpPr>
-          <p:cNvPr id="26" name="Text 24"/>
-          <p:cNvSpPr/>
-          <p:nvPr/>
-        </p:nvSpPr>
-        <p:spPr>
-          <a:xfrm>
-            <a:off x="7552944" y="2670048"/>
-            <a:ext cx="1645920" cy="502920"/>
-          </a:xfrm>
-          <a:prstGeom prst="rect">
-            <a:avLst/>
-          </a:prstGeom>
-          <a:noFill/>
-          <a:ln/>
-        </p:spPr>
-        <p:txBody>
-          <a:bodyPr wrap="square" lIns="0" tIns="0" rIns="0" bIns="0" rtlCol="0" anchor="ctr"/>
-          <a:lstStyle/>
-          <a:p>
-            <a:pPr indent="0" marL="0">
-              <a:buNone/>
-            </a:pPr>
-            <a:r>
-              <a:rPr lang="en-US" sz="2800" b="1" dirty="0">
-                <a:solidFill>
-                  <a:srgbClr val="FFFFFF"/>
-                </a:solidFill>
-                <a:latin typeface="Georgia" pitchFamily="34" charset="0"/>
-                <a:ea typeface="Georgia" pitchFamily="34" charset="-122"/>
-                <a:cs typeface="Georgia" pitchFamily="34" charset="-120"/>
-              </a:rPr>
-              <a:t>$80</a:t>
-            </a:r>
-            <a:pPr indent="0" marL="0">
-              <a:buNone/>
-            </a:pPr>
-            <a:r>
-              <a:rPr lang="en-US" sz="1050" dirty="0">
-                <a:solidFill>
-                  <a:srgbClr val="94A3B8"/>
-                </a:solidFill>
-                <a:latin typeface="Georgia" pitchFamily="34" charset="0"/>
-                <a:ea typeface="Georgia" pitchFamily="34" charset="-122"/>
-                <a:cs typeface="Georgia" pitchFamily="34" charset="-120"/>
-              </a:rPr>
-              <a:t> / mo</a:t>
-            </a:r>
-            <a:endParaRPr lang="en-US" sz="2800" dirty="0"/>
-          </a:p>
-        </p:txBody>
-      </p:sp>
-      <p:sp>
-        <p:nvSpPr>
-          <p:cNvPr id="27" name="Text 25"/>
-          <p:cNvSpPr/>
-          <p:nvPr/>
-        </p:nvSpPr>
-        <p:spPr>
-          <a:xfrm>
-            <a:off x="7552944" y="3273552"/>
-            <a:ext cx="1645920" cy="320040"/>
-          </a:xfrm>
-          <a:prstGeom prst="rect">
-            <a:avLst/>
-          </a:prstGeom>
-          <a:noFill/>
-          <a:ln/>
-        </p:spPr>
-        <p:txBody>
-          <a:bodyPr wrap="square" lIns="0" tIns="0" rIns="0" bIns="0" rtlCol="0" anchor="ctr"/>
-          <a:lstStyle/>
-          <a:p>
-            <a:pPr indent="0" marL="0">
-              <a:buNone/>
-            </a:pPr>
-            <a:r>
-              <a:rPr lang="en-US" sz="1050" b="1" dirty="0">
-                <a:solidFill>
-                  <a:srgbClr val="5EEAD4"/>
-                </a:solidFill>
-                <a:latin typeface="Calibri" pitchFamily="34" charset="0"/>
-                <a:ea typeface="Calibri" pitchFamily="34" charset="-122"/>
-                <a:cs typeface="Calibri" pitchFamily="34" charset="-120"/>
-              </a:rPr>
-              <a:t>25 signed docs / mo</a:t>
-            </a:r>
-            <a:endParaRPr lang="en-US" sz="1050" dirty="0"/>
-          </a:p>
-        </p:txBody>
-      </p:sp>
-      <p:sp>
-        <p:nvSpPr>
-          <p:cNvPr id="28" name="Text 26"/>
-          <p:cNvSpPr/>
-          <p:nvPr/>
-        </p:nvSpPr>
-        <p:spPr>
-          <a:xfrm>
-            <a:off x="7552944" y="3657600"/>
-            <a:ext cx="1645920" cy="1737360"/>
-          </a:xfrm>
-          <a:prstGeom prst="rect">
-            <a:avLst/>
-          </a:prstGeom>
-          <a:noFill/>
-          <a:ln/>
-        </p:spPr>
-        <p:txBody>
-          <a:bodyPr wrap="square" lIns="0" tIns="0" rIns="0" bIns="0" rtlCol="0" anchor="ctr"/>
-          <a:lstStyle/>
-          <a:p>
-            <a:pPr marL="152400" indent="-152400">
-              <a:spcAft>
-                <a:spcPts val="400"/>
-              </a:spcAft>
-              <a:buSzPct val="100000"/>
-              <a:buChar char="✓"/>
-            </a:pPr>
-            <a:r>
-              <a:rPr lang="en-US" sz="1050" dirty="0">
-                <a:solidFill>
-                  <a:srgbClr val="CBD5E1"/>
-                </a:solidFill>
-                <a:latin typeface="Calibri" pitchFamily="34" charset="0"/>
-                <a:ea typeface="Calibri" pitchFamily="34" charset="-122"/>
-                <a:cs typeface="Calibri" pitchFamily="34" charset="-120"/>
-              </a:rPr>
-              <a:t>5 users</a:t>
-            </a:r>
-            <a:endParaRPr lang="en-US" sz="1050" dirty="0"/>
-          </a:p>
-          <a:p>
-            <a:pPr marL="152400" indent="-152400">
-              <a:spcAft>
-                <a:spcPts val="400"/>
-              </a:spcAft>
-              <a:buSzPct val="100000"/>
-              <a:buChar char="✓"/>
-            </a:pPr>
-            <a:r>
-              <a:rPr lang="en-US" sz="1050" dirty="0">
-                <a:solidFill>
-                  <a:srgbClr val="CBD5E1"/>
-                </a:solidFill>
-                <a:latin typeface="Calibri" pitchFamily="34" charset="0"/>
-                <a:ea typeface="Calibri" pitchFamily="34" charset="-122"/>
-                <a:cs typeface="Calibri" pitchFamily="34" charset="-120"/>
-              </a:rPr>
-              <a:t>$3 / extra doc</a:t>
-            </a:r>
-            <a:endParaRPr lang="en-US" sz="1050" dirty="0"/>
-          </a:p>
-          <a:p>
-            <a:pPr marL="152400" indent="-152400">
-              <a:spcAft>
-                <a:spcPts val="400"/>
-              </a:spcAft>
-              <a:buSzPct val="100000"/>
-              <a:buChar char="✓"/>
-            </a:pPr>
-            <a:r>
-              <a:rPr lang="en-US" sz="1050" dirty="0">
-                <a:solidFill>
-                  <a:srgbClr val="CBD5E1"/>
-                </a:solidFill>
-                <a:latin typeface="Calibri" pitchFamily="34" charset="0"/>
-                <a:ea typeface="Calibri" pitchFamily="34" charset="-122"/>
-                <a:cs typeface="Calibri" pitchFamily="34" charset="-120"/>
-              </a:rPr>
-              <a:t>Everything in Standard</a:t>
-            </a:r>
-            <a:endParaRPr lang="en-US" sz="1050" dirty="0"/>
-          </a:p>
-        </p:txBody>
-      </p:sp>
-      <p:sp>
-        <p:nvSpPr>
-          <p:cNvPr id="29" name="Shape 27"/>
-          <p:cNvSpPr/>
-          <p:nvPr/>
-        </p:nvSpPr>
-        <p:spPr>
-          <a:xfrm>
-            <a:off x="9665208" y="1965960"/>
-            <a:ext cx="2011680" cy="3657600"/>
-          </a:xfrm>
-          <a:prstGeom prst="rect">
-            <a:avLst/>
-          </a:prstGeom>
-          <a:solidFill>
-            <a:srgbClr val="FFFFFF"/>
-          </a:solidFill>
-          <a:ln w="12700">
-            <a:solidFill>
-              <a:srgbClr val="E2E8F0"/>
-            </a:solidFill>
-            <a:prstDash val="solid"/>
-          </a:ln>
-          <a:effectLst>
-            <a:outerShdw sx="100000" sy="100000" kx="0" ky="0" algn="bl" rotWithShape="0" blurRad="114300" dist="38100" dir="8100000">
-              <a:srgbClr val="0F172A">
-                <a:alpha val="12000"/>
-              </a:srgbClr>
-            </a:outerShdw>
-          </a:effectLst>
-        </p:spPr>
-      </p:sp>
-      <p:sp>
-        <p:nvSpPr>
-          <p:cNvPr id="30" name="Shape 28"/>
-          <p:cNvSpPr/>
-          <p:nvPr/>
-        </p:nvSpPr>
-        <p:spPr>
-          <a:xfrm>
-            <a:off x="9665208" y="1965960"/>
-            <a:ext cx="2011680" cy="73152"/>
-          </a:xfrm>
-          <a:prstGeom prst="rect">
-            <a:avLst/>
-          </a:prstGeom>
-          <a:solidFill>
-            <a:srgbClr val="65A30D"/>
-          </a:solidFill>
-          <a:ln/>
-        </p:spPr>
-      </p:sp>
-      <p:sp>
-        <p:nvSpPr>
-          <p:cNvPr id="31" name="Text 29"/>
-          <p:cNvSpPr/>
-          <p:nvPr/>
-        </p:nvSpPr>
-        <p:spPr>
-          <a:xfrm>
-            <a:off x="9848088" y="2240280"/>
-            <a:ext cx="1645920" cy="365760"/>
-          </a:xfrm>
-          <a:prstGeom prst="rect">
-            <a:avLst/>
-          </a:prstGeom>
-          <a:noFill/>
-          <a:ln/>
-        </p:spPr>
-        <p:txBody>
-          <a:bodyPr wrap="square" lIns="0" tIns="0" rIns="0" bIns="0" rtlCol="0" anchor="ctr"/>
-          <a:lstStyle/>
-          <a:p>
-            <a:pPr indent="0" marL="0">
-              <a:buNone/>
-            </a:pPr>
-            <a:r>
-              <a:rPr lang="en-US" sz="1600" b="1" dirty="0">
-                <a:solidFill>
-                  <a:srgbClr val="0B1F3A"/>
-                </a:solidFill>
-                <a:latin typeface="Georgia" pitchFamily="34" charset="0"/>
-                <a:ea typeface="Georgia" pitchFamily="34" charset="-122"/>
-                <a:cs typeface="Georgia" pitchFamily="34" charset="-120"/>
-              </a:rPr>
-              <a:t>Ultra</a:t>
-            </a:r>
-            <a:endParaRPr lang="en-US" sz="1600" dirty="0"/>
-          </a:p>
-        </p:txBody>
-      </p:sp>
-      <p:sp>
-        <p:nvSpPr>
-          <p:cNvPr id="32" name="Text 30"/>
-          <p:cNvSpPr/>
-          <p:nvPr/>
-        </p:nvSpPr>
-        <p:spPr>
-          <a:xfrm>
-            <a:off x="9848088" y="2624328"/>
-            <a:ext cx="1645920" cy="502920"/>
-          </a:xfrm>
-          <a:prstGeom prst="rect">
-            <a:avLst/>
-          </a:prstGeom>
-          <a:noFill/>
-          <a:ln/>
-        </p:spPr>
-        <p:txBody>
-          <a:bodyPr wrap="square" lIns="0" tIns="0" rIns="0" bIns="0" rtlCol="0" anchor="ctr"/>
-          <a:lstStyle/>
-          <a:p>
-            <a:pPr indent="0" marL="0">
-              <a:buNone/>
-            </a:pPr>
-            <a:r>
-              <a:rPr lang="en-US" sz="2800" b="1" dirty="0">
-                <a:solidFill>
-                  <a:srgbClr val="0B1F3A"/>
-                </a:solidFill>
-                <a:latin typeface="Georgia" pitchFamily="34" charset="0"/>
-                <a:ea typeface="Georgia" pitchFamily="34" charset="-122"/>
-                <a:cs typeface="Georgia" pitchFamily="34" charset="-120"/>
-              </a:rPr>
-              <a:t>$150</a:t>
-            </a:r>
-            <a:pPr indent="0" marL="0">
-              <a:buNone/>
-            </a:pPr>
-            <a:r>
-              <a:rPr lang="en-US" sz="1050" dirty="0">
-                <a:solidFill>
-                  <a:srgbClr val="64748B"/>
-                </a:solidFill>
-                <a:latin typeface="Georgia" pitchFamily="34" charset="0"/>
-                <a:ea typeface="Georgia" pitchFamily="34" charset="-122"/>
-                <a:cs typeface="Georgia" pitchFamily="34" charset="-120"/>
-              </a:rPr>
-              <a:t> / mo</a:t>
-            </a:r>
-            <a:endParaRPr lang="en-US" sz="2800" dirty="0"/>
-          </a:p>
-        </p:txBody>
-      </p:sp>
-      <p:sp>
-        <p:nvSpPr>
-          <p:cNvPr id="33" name="Text 31"/>
-          <p:cNvSpPr/>
-          <p:nvPr/>
-        </p:nvSpPr>
-        <p:spPr>
-          <a:xfrm>
-            <a:off x="9848088" y="3227832"/>
-            <a:ext cx="1645920" cy="320040"/>
-          </a:xfrm>
-          <a:prstGeom prst="rect">
-            <a:avLst/>
-          </a:prstGeom>
-          <a:noFill/>
-          <a:ln/>
-        </p:spPr>
-        <p:txBody>
-          <a:bodyPr wrap="square" lIns="0" tIns="0" rIns="0" bIns="0" rtlCol="0" anchor="ctr"/>
-          <a:lstStyle/>
-          <a:p>
-            <a:pPr indent="0" marL="0">
-              <a:buNone/>
-            </a:pPr>
-            <a:r>
-              <a:rPr lang="en-US" sz="1050" b="1" dirty="0">
-                <a:solidFill>
-                  <a:srgbClr val="3F6212"/>
-                </a:solidFill>
-                <a:latin typeface="Calibri" pitchFamily="34" charset="0"/>
-                <a:ea typeface="Calibri" pitchFamily="34" charset="-122"/>
-                <a:cs typeface="Calibri" pitchFamily="34" charset="-120"/>
-              </a:rPr>
-              <a:t>50 signed docs / mo</a:t>
-            </a:r>
-            <a:endParaRPr lang="en-US" sz="1050" dirty="0"/>
-          </a:p>
-        </p:txBody>
-      </p:sp>
-      <p:sp>
-        <p:nvSpPr>
-          <p:cNvPr id="34" name="Text 32"/>
-          <p:cNvSpPr/>
-          <p:nvPr/>
-        </p:nvSpPr>
-        <p:spPr>
-          <a:xfrm>
-            <a:off x="9848088" y="3611880"/>
-            <a:ext cx="1645920" cy="1737360"/>
-          </a:xfrm>
-          <a:prstGeom prst="rect">
-            <a:avLst/>
-          </a:prstGeom>
-          <a:noFill/>
-          <a:ln/>
-        </p:spPr>
-        <p:txBody>
-          <a:bodyPr wrap="square" lIns="0" tIns="0" rIns="0" bIns="0" rtlCol="0" anchor="ctr"/>
-          <a:lstStyle/>
-          <a:p>
-            <a:pPr marL="152400" indent="-152400">
-              <a:spcAft>
-                <a:spcPts val="400"/>
-              </a:spcAft>
-              <a:buSzPct val="100000"/>
-              <a:buChar char="✓"/>
-            </a:pPr>
-            <a:r>
-              <a:rPr lang="en-US" sz="1050" dirty="0">
-                <a:solidFill>
-                  <a:srgbClr val="1E293B"/>
-                </a:solidFill>
-                <a:latin typeface="Calibri" pitchFamily="34" charset="0"/>
-                <a:ea typeface="Calibri" pitchFamily="34" charset="-122"/>
-                <a:cs typeface="Calibri" pitchFamily="34" charset="-120"/>
-              </a:rPr>
-              <a:t>10 users</a:t>
-            </a:r>
-            <a:endParaRPr lang="en-US" sz="1050" dirty="0"/>
-          </a:p>
-          <a:p>
-            <a:pPr marL="152400" indent="-152400">
-              <a:spcAft>
-                <a:spcPts val="400"/>
-              </a:spcAft>
-              <a:buSzPct val="100000"/>
-              <a:buChar char="✓"/>
-            </a:pPr>
-            <a:r>
-              <a:rPr lang="en-US" sz="1050" dirty="0">
-                <a:solidFill>
-                  <a:srgbClr val="1E293B"/>
-                </a:solidFill>
-                <a:latin typeface="Calibri" pitchFamily="34" charset="0"/>
-                <a:ea typeface="Calibri" pitchFamily="34" charset="-122"/>
-                <a:cs typeface="Calibri" pitchFamily="34" charset="-120"/>
-              </a:rPr>
-              <a:t>$3 / extra doc</a:t>
-            </a:r>
-            <a:endParaRPr lang="en-US" sz="1050" dirty="0"/>
-          </a:p>
-          <a:p>
-            <a:pPr marL="152400" indent="-152400">
-              <a:spcAft>
-                <a:spcPts val="400"/>
-              </a:spcAft>
-              <a:buSzPct val="100000"/>
-              <a:buChar char="✓"/>
-            </a:pPr>
-            <a:r>
-              <a:rPr lang="en-US" sz="1050" dirty="0">
-                <a:solidFill>
-                  <a:srgbClr val="1E293B"/>
-                </a:solidFill>
-                <a:latin typeface="Calibri" pitchFamily="34" charset="0"/>
-                <a:ea typeface="Calibri" pitchFamily="34" charset="-122"/>
-                <a:cs typeface="Calibri" pitchFamily="34" charset="-120"/>
-              </a:rPr>
-              <a:t>Best per-doc rate</a:t>
-            </a:r>
-            <a:endParaRPr lang="en-US" sz="1050" dirty="0"/>
-          </a:p>
-          <a:p>
-            <a:pPr marL="152400" indent="-152400">
-              <a:spcAft>
-                <a:spcPts val="400"/>
-              </a:spcAft>
-              <a:buSzPct val="100000"/>
-              <a:buChar char="✓"/>
-            </a:pPr>
-            <a:r>
-              <a:rPr lang="en-US" sz="1050" dirty="0">
-                <a:solidFill>
-                  <a:srgbClr val="1E293B"/>
-                </a:solidFill>
-                <a:latin typeface="Calibri" pitchFamily="34" charset="0"/>
-                <a:ea typeface="Calibri" pitchFamily="34" charset="-122"/>
-                <a:cs typeface="Calibri" pitchFamily="34" charset="-120"/>
-              </a:rPr>
-              <a:t>Everything in Pro</a:t>
-            </a:r>
-            <a:endParaRPr lang="en-US" sz="1050" dirty="0"/>
-          </a:p>
-        </p:txBody>
-      </p:sp>
-      <p:sp>
-        <p:nvSpPr>
-          <p:cNvPr id="35" name="Text 33"/>
-          <p:cNvSpPr/>
-          <p:nvPr/>
-        </p:nvSpPr>
-        <p:spPr>
-          <a:xfrm>
-            <a:off x="822960" y="5989320"/>
-            <a:ext cx="10515600" cy="548640"/>
-          </a:xfrm>
-          <a:prstGeom prst="rect">
-            <a:avLst/>
-          </a:prstGeom>
-          <a:noFill/>
-          <a:ln/>
-        </p:spPr>
-        <p:txBody>
-          <a:bodyPr wrap="square" lIns="0" tIns="0" rIns="0" bIns="0" rtlCol="0" anchor="ctr"/>
-          <a:lstStyle/>
-          <a:p>
-            <a:pPr algn="ctr" indent="0" marL="0">
-              <a:buNone/>
-            </a:pPr>
-            <a:r>
-              <a:rPr lang="en-US" sz="1100" i="1" dirty="0">
-                <a:solidFill>
-                  <a:srgbClr val="64748B"/>
-                </a:solidFill>
-                <a:latin typeface="Calibri" pitchFamily="34" charset="0"/>
-                <a:ea typeface="Calibri" pitchFamily="34" charset="-122"/>
-                <a:cs typeface="Calibri" pitchFamily="34" charset="-120"/>
-              </a:rPr>
-              <a:t>Flat $3 per completed document beyond your plan's monthly included docs — any plan, never a hard cap. Users are fixed per plan (no seat add-ons); AI proposal drafting is included on every plan. Annual billing (~2 months free). Pricing is being finalized during beta — contact hello@smartprops.io.</a:t>
-            </a:r>
-            <a:endParaRPr lang="en-US" sz="1100" dirty="0"/>
-          </a:p>
-        </p:txBody>
-      </p:sp>
-    </p:spTree>
-  </p:cSld>
-  <p:clrMapOvr>
-    <a:masterClrMapping/>
-  </p:clrMapOvr>
-</p:sld>
-</file>
-
-<file path=ppt/slides/slide8.xml><?xml version="1.0" encoding="utf-8"?>
-<p:sld xmlns:a="http://schemas.openxmlformats.org/drawingml/2006/main" xmlns:r="http://schemas.openxmlformats.org/officeDocument/2006/relationships" xmlns:p="http://schemas.openxmlformats.org/presentationml/2006/main">
-  <p:cSld name="Slide 8">
     <p:bg>
       <p:bgPr>
         <a:solidFill>

</xml_diff>